<commit_message>
fix: OPT = slides optionnelles absentes de la version, conclusion incluse
- Remplace le filtre fixe (full list, exclusion conclusion) par un
  filtre dynamique : optionnel=True ET slide absente des indices
  de la version courante
- role=conclusion inclus si marqué optionnel (ex. slide 15 B10)
- Limite [:2] retirée (toutes les optionnelles de la version sont affichées)
- complet → OPT vide (toutes les slides déjà incluses)
- 1h / 1h30 → B10 passe de 1 OPT à 2 OPT (slides 12 + 15)
- 60 fiches regénérées

Co-Authored-By: Claude Sonnet 4.6 <noreply@anthropic.com>
Claude-Session: https://claude.ai/code/session_01GGjUeQAdhFHN5BAn7y22FV
</commit_message>
<xml_diff>
--- a/assets/fiches/A6-fiche-complet.pptx
+++ b/assets/fiches/A6-fiche-complet.pptx
@@ -6725,300 +6725,6 @@
         </p:nvSpPr>
         <p:spPr>
           <a:xfrm>
-            <a:off x="529200" y="3625200"/>
-            <a:ext cx="6498000" cy="1065600"/>
-          </a:xfrm>
-          <a:prstGeom prst="rect">
-            <a:avLst/>
-          </a:prstGeom>
-          <a:solidFill>
-            <a:srgbClr val="FFF8EF"/>
-          </a:solidFill>
-          <a:ln w="19050">
-            <a:solidFill>
-              <a:srgbClr val="E67D21"/>
-            </a:solidFill>
-          </a:ln>
-        </p:spPr>
-        <p:style>
-          <a:lnRef idx="1">
-            <a:schemeClr val="accent1"/>
-          </a:lnRef>
-          <a:fillRef idx="3">
-            <a:schemeClr val="accent1"/>
-          </a:fillRef>
-          <a:effectRef idx="2">
-            <a:schemeClr val="accent1"/>
-          </a:effectRef>
-          <a:fontRef idx="minor">
-            <a:schemeClr val="lt1"/>
-          </a:fontRef>
-        </p:style>
-        <p:txBody>
-          <a:bodyPr rtlCol="0" anchor="ctr"/>
-          <a:lstStyle/>
-          <a:p/>
-        </p:txBody>
-      </p:sp>
-      <p:sp>
-        <p:nvSpPr>
-          <p:cNvPr id="23" name="Rectangle 22"/>
-          <p:cNvSpPr/>
-          <p:nvPr/>
-        </p:nvSpPr>
-        <p:spPr>
-          <a:xfrm>
-            <a:off x="529200" y="3625200"/>
-            <a:ext cx="6498000" cy="198000"/>
-          </a:xfrm>
-          <a:prstGeom prst="rect">
-            <a:avLst/>
-          </a:prstGeom>
-          <a:solidFill>
-            <a:srgbClr val="E67D21"/>
-          </a:solidFill>
-          <a:ln>
-            <a:noFill/>
-          </a:ln>
-        </p:spPr>
-        <p:style>
-          <a:lnRef idx="1">
-            <a:schemeClr val="accent1"/>
-          </a:lnRef>
-          <a:fillRef idx="3">
-            <a:schemeClr val="accent1"/>
-          </a:fillRef>
-          <a:effectRef idx="2">
-            <a:schemeClr val="accent1"/>
-          </a:effectRef>
-          <a:fontRef idx="minor">
-            <a:schemeClr val="lt1"/>
-          </a:fontRef>
-        </p:style>
-        <p:txBody>
-          <a:bodyPr rtlCol="0" anchor="ctr"/>
-          <a:lstStyle/>
-          <a:p/>
-        </p:txBody>
-      </p:sp>
-      <p:sp>
-        <p:nvSpPr>
-          <p:cNvPr id="24" name="TextBox 23"/>
-          <p:cNvSpPr txBox="1"/>
-          <p:nvPr/>
-        </p:nvSpPr>
-        <p:spPr>
-          <a:xfrm>
-            <a:off x="601200" y="3654000"/>
-            <a:ext cx="6354000" cy="162000"/>
-          </a:xfrm>
-          <a:prstGeom prst="rect">
-            <a:avLst/>
-          </a:prstGeom>
-          <a:noFill/>
-        </p:spPr>
-        <p:txBody>
-          <a:bodyPr wrap="square" tIns="0" bIns="0" lIns="18000" rIns="18000">
-            <a:spAutoFit/>
-          </a:bodyPr>
-          <a:lstStyle/>
-          <a:p>
-            <a:pPr algn="ctr">
-              <a:spcBef>
-                <a:spcPts val="0"/>
-              </a:spcBef>
-              <a:spcAft>
-                <a:spcPts val="100"/>
-              </a:spcAft>
-            </a:pPr>
-            <a:r>
-              <a:rPr sz="850" b="1" i="0">
-                <a:solidFill>
-                  <a:srgbClr val="FFFFFF"/>
-                </a:solidFill>
-                <a:latin typeface="Arial"/>
-              </a:rPr>
-              <a:t>Blocs optionnels — À aborder si le temps le permet</a:t>
-            </a:r>
-          </a:p>
-        </p:txBody>
-      </p:sp>
-      <p:sp>
-        <p:nvSpPr>
-          <p:cNvPr id="25" name="Rectangle 24"/>
-          <p:cNvSpPr/>
-          <p:nvPr/>
-        </p:nvSpPr>
-        <p:spPr>
-          <a:xfrm>
-            <a:off x="529200" y="3823200"/>
-            <a:ext cx="6498000" cy="14400"/>
-          </a:xfrm>
-          <a:prstGeom prst="rect">
-            <a:avLst/>
-          </a:prstGeom>
-          <a:solidFill>
-            <a:srgbClr val="E67D21"/>
-          </a:solidFill>
-          <a:ln>
-            <a:noFill/>
-          </a:ln>
-        </p:spPr>
-        <p:style>
-          <a:lnRef idx="1">
-            <a:schemeClr val="accent1"/>
-          </a:lnRef>
-          <a:fillRef idx="3">
-            <a:schemeClr val="accent1"/>
-          </a:fillRef>
-          <a:effectRef idx="2">
-            <a:schemeClr val="accent1"/>
-          </a:effectRef>
-          <a:fontRef idx="minor">
-            <a:schemeClr val="lt1"/>
-          </a:fontRef>
-        </p:style>
-        <p:txBody>
-          <a:bodyPr rtlCol="0" anchor="ctr"/>
-          <a:lstStyle/>
-          <a:p/>
-        </p:txBody>
-      </p:sp>
-      <p:sp>
-        <p:nvSpPr>
-          <p:cNvPr id="26" name="TextBox 25"/>
-          <p:cNvSpPr txBox="1"/>
-          <p:nvPr/>
-        </p:nvSpPr>
-        <p:spPr>
-          <a:xfrm>
-            <a:off x="637200" y="3866400"/>
-            <a:ext cx="6300000" cy="766800"/>
-          </a:xfrm>
-          <a:prstGeom prst="rect">
-            <a:avLst/>
-          </a:prstGeom>
-          <a:noFill/>
-        </p:spPr>
-        <p:txBody>
-          <a:bodyPr wrap="square" tIns="0" bIns="0" lIns="18000" rIns="18000">
-            <a:spAutoFit/>
-          </a:bodyPr>
-          <a:lstStyle/>
-          <a:p>
-            <a:pPr algn="l">
-              <a:spcBef>
-                <a:spcPts val="0"/>
-              </a:spcBef>
-              <a:spcAft>
-                <a:spcPts val="100"/>
-              </a:spcAft>
-            </a:pPr>
-            <a:r>
-              <a:rPr sz="800" b="1" i="0">
-                <a:solidFill>
-                  <a:srgbClr val="E67D21"/>
-                </a:solidFill>
-                <a:latin typeface="Arial"/>
-              </a:rPr>
-              <a:t>8 min</a:t>
-            </a:r>
-          </a:p>
-          <a:p>
-            <a:pPr algn="l">
-              <a:spcBef>
-                <a:spcPts val="0"/>
-              </a:spcBef>
-              <a:spcAft>
-                <a:spcPts val="100"/>
-              </a:spcAft>
-            </a:pPr>
-            <a:r>
-              <a:rPr sz="900" b="1" i="0">
-                <a:solidFill>
-                  <a:srgbClr val="2B2B2B"/>
-                </a:solidFill>
-                <a:latin typeface="Arial"/>
-              </a:rPr>
-              <a:t>Numérique responsable</a:t>
-            </a:r>
-          </a:p>
-          <a:p>
-            <a:pPr>
-              <a:spcBef>
-                <a:spcPts val="0"/>
-              </a:spcBef>
-              <a:spcAft>
-                <a:spcPts val="100"/>
-              </a:spcAft>
-            </a:pPr>
-            <a:r>
-              <a:rPr sz="800" b="1">
-                <a:solidFill>
-                  <a:srgbClr val="E67D21"/>
-                </a:solidFill>
-                <a:latin typeface="Arial"/>
-              </a:rPr>
-              <a:t>OPT.  </a:t>
-            </a:r>
-            <a:r>
-              <a:rPr sz="800">
-                <a:solidFill>
-                  <a:srgbClr val="2B2B2B"/>
-                </a:solidFill>
-                <a:latin typeface="Arial"/>
-              </a:rPr>
-              <a:t>. Sécurité et sobriété numérique : deux alliés</a:t>
-            </a:r>
-          </a:p>
-          <a:p>
-            <a:pPr algn="l">
-              <a:spcBef>
-                <a:spcPts val="0"/>
-              </a:spcBef>
-              <a:spcAft>
-                <a:spcPts val="100"/>
-              </a:spcAft>
-            </a:pPr>
-            <a:r>
-              <a:rPr sz="800" b="0" i="0">
-                <a:solidFill>
-                  <a:srgbClr val="2B2B2B"/>
-                </a:solidFill>
-                <a:latin typeface="Arial"/>
-              </a:rPr>
-              <a:t>. La sécurité numérique et la sobriété vont de pair. Moins d'applications ins…</a:t>
-            </a:r>
-          </a:p>
-          <a:p>
-            <a:pPr algn="l">
-              <a:spcBef>
-                <a:spcPts val="0"/>
-              </a:spcBef>
-              <a:spcAft>
-                <a:spcPts val="100"/>
-              </a:spcAft>
-            </a:pPr>
-            <a:r>
-              <a:rPr sz="800" b="0" i="0">
-                <a:solidFill>
-                  <a:srgbClr val="2B2B2B"/>
-                </a:solidFill>
-                <a:latin typeface="Arial"/>
-              </a:rPr>
-              <a:t>. Faites le ménage dans vos applications</a:t>
-            </a:r>
-          </a:p>
-        </p:txBody>
-      </p:sp>
-      <p:sp>
-        <p:nvSpPr>
-          <p:cNvPr id="27" name="Rectangle 26"/>
-          <p:cNvSpPr/>
-          <p:nvPr/>
-        </p:nvSpPr>
-        <p:spPr>
-          <a:xfrm>
             <a:off x="529200" y="9684000"/>
             <a:ext cx="6498000" cy="43200"/>
           </a:xfrm>
@@ -7054,7 +6760,7 @@
       </p:sp>
       <p:sp>
         <p:nvSpPr>
-          <p:cNvPr id="28" name="TextBox 27"/>
+          <p:cNvPr id="23" name="TextBox 22"/>
           <p:cNvSpPr txBox="1"/>
           <p:nvPr/>
         </p:nvSpPr>

</xml_diff>